<commit_message>
docs: add real deployment & app screenshots directly embedded in presentation PPTX
</commit_message>
<xml_diff>
--- a/Movie_Sentiment_Analysis_Presentation.pptx
+++ b/Movie_Sentiment_Analysis_Presentation.pptx
@@ -3111,7 +3111,7 @@
         <p:spPr>
           <a:xfrm>
             <a:off x="914400" y="1645920"/>
-            <a:ext cx="10332720" cy="3657600"/>
+            <a:ext cx="10332720" cy="4114800"/>
           </a:xfrm>
           <a:prstGeom prst="rect">
             <a:avLst/>
@@ -3119,7 +3119,7 @@
           <a:noFill/>
         </p:spPr>
         <p:txBody>
-          <a:bodyPr wrap="square">
+          <a:bodyPr wrap="none">
             <a:spAutoFit/>
           </a:bodyPr>
           <a:lstStyle/>
@@ -3140,14 +3140,14 @@
               <a:spcBef>
                 <a:spcPts val="1400"/>
               </a:spcBef>
-              <a:defRPr sz="2000">
+              <a:defRPr sz="1900">
                 <a:solidFill>
                   <a:srgbClr val="F8FAFC"/>
                 </a:solidFill>
               </a:defRPr>
             </a:pPr>
             <a:r>
-              <a:t>Production-Grade Machine Learning Web Application with Cloud Deployment</a:t>
+              <a:t>Production-Grade Machine Learning Web Platform with Full Cloud Deployment</a:t>
             </a:r>
           </a:p>
           <a:p>
@@ -3155,22 +3155,22 @@
               <a:spcBef>
                 <a:spcPts val="2400"/>
               </a:spcBef>
-              <a:defRPr sz="1300">
+              <a:defRPr sz="1400">
                 <a:solidFill>
                   <a:srgbClr val="94A3B8"/>
                 </a:solidFill>
               </a:defRPr>
             </a:pPr>
             <a:r>
-              <a:t>Live Frontend: https://movie-sentiment-app-6yekngedx7cuisepgfajja.streamlit.app/</a:t>
+              <a:t>🌐 Live App: https://movie-sentiment-app-6yekngedx7cuisepgfajja.streamlit.app/</a:t>
             </a:r>
             <a:br/>
             <a:r>
-              <a:t>Live Backend API: https://movie-sentiment-api-cum3.onrender.com/</a:t>
+              <a:t>⚙️ Live API: https://movie-sentiment-api-cum3.onrender.com/</a:t>
             </a:r>
             <a:br/>
             <a:r>
-              <a:t>Tech Stack: Python • FastAPI • Streamlit • Scikit-Learn • Render • Streamlit Cloud</a:t>
+              <a:t>📂 GitHub: https://github.com/shivam972410-lang/movie-sentiment-app</a:t>
             </a:r>
           </a:p>
         </p:txBody>
@@ -3209,8 +3209,8 @@
         </p:nvSpPr>
         <p:spPr>
           <a:xfrm>
-            <a:off x="731520" y="457200"/>
-            <a:ext cx="10698480" cy="1005840"/>
+            <a:off x="731520" y="365760"/>
+            <a:ext cx="10698480" cy="914400"/>
           </a:xfrm>
           <a:prstGeom prst="rect">
             <a:avLst/>
@@ -3231,33 +3231,57 @@
               </a:defRPr>
             </a:pPr>
             <a:r>
-              <a:t>CLOUD INFRASTRUCTURE</a:t>
+              <a:t>BACKEND INFRASTRUCTURE</a:t>
             </a:r>
           </a:p>
           <a:p>
             <a:pPr>
-              <a:defRPr sz="2600" b="1">
+              <a:defRPr sz="2400" b="1">
                 <a:solidFill>
                   <a:srgbClr val="F8FAFC"/>
                 </a:solidFill>
               </a:defRPr>
             </a:pPr>
             <a:r>
-              <a:t>Full Cloud Deployment Architecture</a:t>
-            </a:r>
-          </a:p>
-        </p:txBody>
-      </p:sp>
-      <p:sp>
-        <p:nvSpPr>
-          <p:cNvPr id="3" name="TextBox 2"/>
+              <a:t>Cloud Deployment &amp; Live Render Backend</a:t>
+            </a:r>
+          </a:p>
+        </p:txBody>
+      </p:sp>
+      <p:pic>
+        <p:nvPicPr>
+          <p:cNvPr id="3" name="Picture 2" descr="1_render_deployment_live.png"/>
+          <p:cNvPicPr>
+            <a:picLocks noChangeAspect="1"/>
+          </p:cNvPicPr>
+          <p:nvPr/>
+        </p:nvPicPr>
+        <p:blipFill>
+          <a:blip r:embed="rId2"/>
+          <a:stretch>
+            <a:fillRect/>
+          </a:stretch>
+        </p:blipFill>
+        <p:spPr>
+          <a:xfrm>
+            <a:off x="731520" y="1463040"/>
+            <a:ext cx="5852160" cy="3489413"/>
+          </a:xfrm>
+          <a:prstGeom prst="rect">
+            <a:avLst/>
+          </a:prstGeom>
+        </p:spPr>
+      </p:pic>
+      <p:sp>
+        <p:nvSpPr>
+          <p:cNvPr id="4" name="TextBox 3"/>
           <p:cNvSpPr txBox="1"/>
           <p:nvPr/>
         </p:nvSpPr>
         <p:spPr>
           <a:xfrm>
-            <a:off x="731520" y="1645920"/>
-            <a:ext cx="10698480" cy="4572000"/>
+            <a:off x="6766560" y="1463040"/>
+            <a:ext cx="4663440" cy="4754880"/>
           </a:xfrm>
           <a:prstGeom prst="rect">
             <a:avLst/>
@@ -3273,76 +3297,76 @@
           <a:p>
             <a:pPr>
               <a:spcAft>
-                <a:spcPts val="1000"/>
+                <a:spcPts val="800"/>
               </a:spcAft>
-              <a:defRPr sz="1500">
+              <a:defRPr sz="1300">
                 <a:solidFill>
                   <a:srgbClr val="F5C518"/>
                 </a:solidFill>
               </a:defRPr>
             </a:pPr>
             <a:r>
-              <a:t>🌐 Live Streamlit Frontend: https://movie-sentiment-app-6yekngedx7cuisepgfajja.streamlit.app/ (Zero-install web UI on Streamlit Community Cloud)</a:t>
+              <a:t>Render Cloud Deployment: FastAPI service deployed on Render Global Edge network with automatic health monitoring.</a:t>
             </a:r>
           </a:p>
           <a:p>
             <a:pPr>
               <a:spcAft>
-                <a:spcPts val="1000"/>
+                <a:spcPts val="800"/>
               </a:spcAft>
-              <a:defRPr sz="1500">
-                <a:solidFill>
-                  <a:srgbClr val="F5C518"/>
+              <a:defRPr sz="1300">
+                <a:solidFill>
+                  <a:srgbClr val="22C55E"/>
                 </a:solidFill>
               </a:defRPr>
             </a:pPr>
             <a:r>
-              <a:t>⚙️ Live FastAPI REST Backend: https://movie-sentiment-api-cum3.onrender.com (High-throughput async ML API deployed on Render Cloud)</a:t>
+              <a:t>Live Primary URL: https://movie-sentiment-api-cum3.onrender.com (Running on Port 10000)</a:t>
             </a:r>
           </a:p>
           <a:p>
             <a:pPr>
               <a:spcAft>
-                <a:spcPts val="1000"/>
+                <a:spcPts val="800"/>
               </a:spcAft>
-              <a:defRPr sz="1500">
+              <a:defRPr sz="1300">
                 <a:solidFill>
                   <a:srgbClr val="F8FAFC"/>
                 </a:solidFill>
               </a:defRPr>
             </a:pPr>
             <a:r>
-              <a:t>📦 GitHub CI/CD Pipeline: Connected repository: shivam972410-lang/movie-sentiment-app. Every 'git push origin main' automatically triggers live redeployment on both clouds.</a:t>
+              <a:t>Startup Command: uvicorn main:app --host 0.0.0.0 --port </a:t>
             </a:r>
           </a:p>
           <a:p>
             <a:pPr>
               <a:spcAft>
-                <a:spcPts val="1000"/>
+                <a:spcPts val="800"/>
               </a:spcAft>
-              <a:defRPr sz="1500">
+              <a:defRPr sz="1300">
                 <a:solidFill>
                   <a:srgbClr val="F8FAFC"/>
                 </a:solidFill>
               </a:defRPr>
             </a:pPr>
             <a:r>
-              <a:t>🔄 Decoupled Microservices: Frontend and Backend run independently in separate server environments, communicating over secure HTTPS REST protocols.</a:t>
+              <a:t>Auto GitHub Sync: Every commit pushed to main branch triggers automatic zero-downtime deployment.</a:t>
             </a:r>
           </a:p>
           <a:p>
             <a:pPr>
               <a:spcAft>
-                <a:spcPts val="1000"/>
+                <a:spcPts val="800"/>
               </a:spcAft>
-              <a:defRPr sz="1500">
+              <a:defRPr sz="1300">
                 <a:solidFill>
                   <a:srgbClr val="22C55E"/>
                 </a:solidFill>
               </a:defRPr>
             </a:pPr>
             <a:r>
-              <a:t>⚡ 24/7 Global Availability: Accessible instantly on any device (Mobile, Mac, Windows, Linux) without requiring Python or terminal setup.</a:t>
+              <a:t>Production Health: /health endpoint actively confirms model_loaded: true with sub-second latency.</a:t>
             </a:r>
           </a:p>
         </p:txBody>
@@ -3381,8 +3405,8 @@
         </p:nvSpPr>
         <p:spPr>
           <a:xfrm>
-            <a:off x="731520" y="457200"/>
-            <a:ext cx="10698480" cy="1005840"/>
+            <a:off x="731520" y="365760"/>
+            <a:ext cx="10698480" cy="914400"/>
           </a:xfrm>
           <a:prstGeom prst="rect">
             <a:avLst/>
@@ -3403,33 +3427,57 @@
               </a:defRPr>
             </a:pPr>
             <a:r>
-              <a:t>BACKEND SETUP GUIDE</a:t>
+              <a:t>FRONTEND MODULE 1</a:t>
             </a:r>
           </a:p>
           <a:p>
             <a:pPr>
-              <a:defRPr sz="2600" b="1">
+              <a:defRPr sz="2400" b="1">
                 <a:solidFill>
                   <a:srgbClr val="F8FAFC"/>
                 </a:solidFill>
               </a:defRPr>
             </a:pPr>
             <a:r>
-              <a:t>Step-by-Step Backend Deployment on Render</a:t>
-            </a:r>
-          </a:p>
-        </p:txBody>
-      </p:sp>
-      <p:sp>
-        <p:nvSpPr>
-          <p:cNvPr id="3" name="TextBox 2"/>
+              <a:t>Real-Time Sentiment Classification &amp; Explainable AI</a:t>
+            </a:r>
+          </a:p>
+        </p:txBody>
+      </p:sp>
+      <p:pic>
+        <p:nvPicPr>
+          <p:cNvPr id="3" name="Picture 2" descr="2_live_review_prediction.png"/>
+          <p:cNvPicPr>
+            <a:picLocks noChangeAspect="1"/>
+          </p:cNvPicPr>
+          <p:nvPr/>
+        </p:nvPicPr>
+        <p:blipFill>
+          <a:blip r:embed="rId2"/>
+          <a:stretch>
+            <a:fillRect/>
+          </a:stretch>
+        </p:blipFill>
+        <p:spPr>
+          <a:xfrm>
+            <a:off x="731520" y="1463040"/>
+            <a:ext cx="5852160" cy="3458340"/>
+          </a:xfrm>
+          <a:prstGeom prst="rect">
+            <a:avLst/>
+          </a:prstGeom>
+        </p:spPr>
+      </p:pic>
+      <p:sp>
+        <p:nvSpPr>
+          <p:cNvPr id="4" name="TextBox 3"/>
           <p:cNvSpPr txBox="1"/>
           <p:nvPr/>
         </p:nvSpPr>
         <p:spPr>
           <a:xfrm>
-            <a:off x="731520" y="1645920"/>
-            <a:ext cx="10698480" cy="4572000"/>
+            <a:off x="6766560" y="1463040"/>
+            <a:ext cx="4663440" cy="4754880"/>
           </a:xfrm>
           <a:prstGeom prst="rect">
             <a:avLst/>
@@ -3445,76 +3493,76 @@
           <a:p>
             <a:pPr>
               <a:spcAft>
-                <a:spcPts val="1000"/>
+                <a:spcPts val="800"/>
               </a:spcAft>
-              <a:defRPr sz="1500">
-                <a:solidFill>
-                  <a:srgbClr val="F8FAFC"/>
+              <a:defRPr sz="1300">
+                <a:solidFill>
+                  <a:srgbClr val="F5C518"/>
                 </a:solidFill>
               </a:defRPr>
             </a:pPr>
             <a:r>
-              <a:t>Step 1 • Render Account &amp; Git Link: Create account on dashboard.render.com and link GitHub repo 'shivam972410-lang/movie-sentiment-app'.</a:t>
+              <a:t>Streamlit Cloud URL: https://movie-sentiment-app-6yekngedx7cuisepgfajja.streamlit.app/</a:t>
             </a:r>
           </a:p>
           <a:p>
             <a:pPr>
               <a:spcAft>
-                <a:spcPts val="1000"/>
+                <a:spcPts val="800"/>
               </a:spcAft>
-              <a:defRPr sz="1500">
+              <a:defRPr sz="1300">
                 <a:solidFill>
                   <a:srgbClr val="F8FAFC"/>
                 </a:solidFill>
               </a:defRPr>
             </a:pPr>
             <a:r>
-              <a:t>Step 2 • Web Service Configuration: Select 'Web Service' with Python 3 environment, located in Singapore/Frankfurt region.</a:t>
+              <a:t>Instant Predictions: Processes custom user reviews in real time using scikit-learn TF-IDF + Logistic Regression.</a:t>
             </a:r>
           </a:p>
           <a:p>
             <a:pPr>
               <a:spcAft>
-                <a:spcPts val="1000"/>
+                <a:spcPts val="800"/>
               </a:spcAft>
-              <a:defRPr sz="1500">
+              <a:defRPr sz="1300">
                 <a:solidFill>
                   <a:srgbClr val="F8FAFC"/>
                 </a:solidFill>
               </a:defRPr>
             </a:pPr>
             <a:r>
-              <a:t>Step 3 • Build Command: pip install -r requirements.txt (installs FastAPI, Scikit-Learn, Uvicorn, Pandas, etc.)</a:t>
+              <a:t>Calibrated Confidence: Outputs precise positive vs. negative probability percentages (e.g. 97.4% vs 2.6%).</a:t>
             </a:r>
           </a:p>
           <a:p>
             <a:pPr>
               <a:spcAft>
-                <a:spcPts val="1000"/>
+                <a:spcPts val="800"/>
               </a:spcAft>
-              <a:defRPr sz="1500">
-                <a:solidFill>
-                  <a:srgbClr val="F8FAFC"/>
+              <a:defRPr sz="1300">
+                <a:solidFill>
+                  <a:srgbClr val="22C55E"/>
                 </a:solidFill>
               </a:defRPr>
             </a:pPr>
             <a:r>
-              <a:t>Step 4 • Start Command: uvicorn main:app --host 0.0.0.0 --port  (binds dynamically to Render's allocated cloud port)</a:t>
+              <a:t>Explainable AI (XAI): Highlights key words that influenced the prediction (e.g. 'masterpiece', 'stellar').</a:t>
             </a:r>
           </a:p>
           <a:p>
             <a:pPr>
               <a:spcAft>
-                <a:spcPts val="1000"/>
+                <a:spcPts val="800"/>
               </a:spcAft>
-              <a:defRPr sz="1500">
-                <a:solidFill>
-                  <a:srgbClr val="22C55E"/>
+              <a:defRPr sz="1300">
+                <a:solidFill>
+                  <a:srgbClr val="F8FAFC"/>
                 </a:solidFill>
               </a:defRPr>
             </a:pPr>
             <a:r>
-              <a:t>Step 5 • Live Verification: API returns 200 OK at /health with model_loaded: true and documentation at /docs.</a:t>
+              <a:t>Threshold Safeguard: Reviews below 60% confidence are safely tagged as Neutral/Uncertain to prevent bias.</a:t>
             </a:r>
           </a:p>
         </p:txBody>
@@ -3553,8 +3601,8 @@
         </p:nvSpPr>
         <p:spPr>
           <a:xfrm>
-            <a:off x="731520" y="457200"/>
-            <a:ext cx="10698480" cy="1005840"/>
+            <a:off x="731520" y="365760"/>
+            <a:ext cx="10698480" cy="914400"/>
           </a:xfrm>
           <a:prstGeom prst="rect">
             <a:avLst/>
@@ -3575,33 +3623,57 @@
               </a:defRPr>
             </a:pPr>
             <a:r>
-              <a:t>FRONTEND SETUP GUIDE</a:t>
+              <a:t>FRONTEND MODULE 2</a:t>
             </a:r>
           </a:p>
           <a:p>
             <a:pPr>
-              <a:defRPr sz="2600" b="1">
+              <a:defRPr sz="2400" b="1">
                 <a:solidFill>
                   <a:srgbClr val="F8FAFC"/>
                 </a:solidFill>
               </a:defRPr>
             </a:pPr>
             <a:r>
-              <a:t>Step-by-Step Frontend Deployment on Streamlit Cloud</a:t>
-            </a:r>
-          </a:p>
-        </p:txBody>
-      </p:sp>
-      <p:sp>
-        <p:nvSpPr>
-          <p:cNvPr id="3" name="TextBox 2"/>
+              <a:t>Movie Explorer &amp; Narrative Plot Tone AI</a:t>
+            </a:r>
+          </a:p>
+        </p:txBody>
+      </p:sp>
+      <p:pic>
+        <p:nvPicPr>
+          <p:cNvPr id="3" name="Picture 2" descr="3_movie_explorer_sanju.png"/>
+          <p:cNvPicPr>
+            <a:picLocks noChangeAspect="1"/>
+          </p:cNvPicPr>
+          <p:nvPr/>
+        </p:nvPicPr>
+        <p:blipFill>
+          <a:blip r:embed="rId2"/>
+          <a:stretch>
+            <a:fillRect/>
+          </a:stretch>
+        </p:blipFill>
+        <p:spPr>
+          <a:xfrm>
+            <a:off x="731520" y="1463040"/>
+            <a:ext cx="5852160" cy="3469553"/>
+          </a:xfrm>
+          <a:prstGeom prst="rect">
+            <a:avLst/>
+          </a:prstGeom>
+        </p:spPr>
+      </p:pic>
+      <p:sp>
+        <p:nvSpPr>
+          <p:cNvPr id="4" name="TextBox 3"/>
           <p:cNvSpPr txBox="1"/>
           <p:nvPr/>
         </p:nvSpPr>
         <p:spPr>
           <a:xfrm>
-            <a:off x="731520" y="1645920"/>
-            <a:ext cx="10698480" cy="4572000"/>
+            <a:off x="6766560" y="1463040"/>
+            <a:ext cx="4663440" cy="4754880"/>
           </a:xfrm>
           <a:prstGeom prst="rect">
             <a:avLst/>
@@ -3617,76 +3689,76 @@
           <a:p>
             <a:pPr>
               <a:spcAft>
-                <a:spcPts val="1000"/>
+                <a:spcPts val="800"/>
               </a:spcAft>
-              <a:defRPr sz="1500">
-                <a:solidFill>
-                  <a:srgbClr val="F8FAFC"/>
+              <a:defRPr sz="1300">
+                <a:solidFill>
+                  <a:srgbClr val="F5C518"/>
                 </a:solidFill>
               </a:defRPr>
             </a:pPr>
             <a:r>
-              <a:t>Step 1 • Streamlit Cloud Sign-In: Navigate to share.streamlit.io and authorize via GitHub account.</a:t>
+              <a:t>58+ Film Catalog: Extensive library covering Indian (Bollywood/Tollywood) and International cinema.</a:t>
             </a:r>
           </a:p>
           <a:p>
             <a:pPr>
               <a:spcAft>
-                <a:spcPts val="1000"/>
+                <a:spcPts val="800"/>
               </a:spcAft>
-              <a:defRPr sz="1500">
-                <a:solidFill>
-                  <a:srgbClr val="F8FAFC"/>
+              <a:defRPr sz="1300">
+                <a:solidFill>
+                  <a:srgbClr val="22C55E"/>
                 </a:solidFill>
               </a:defRPr>
             </a:pPr>
             <a:r>
-              <a:t>Step 2 • Repository &amp; Branch Selection: Select repository 'movie-sentiment-app' and branch 'main'.</a:t>
+              <a:t>Local Poster Cache: 58 high-resolution posters bundled locally to prevent Wikimedia CDN 429 rate-limiting.</a:t>
             </a:r>
           </a:p>
           <a:p>
             <a:pPr>
               <a:spcAft>
-                <a:spcPts val="1000"/>
+                <a:spcPts val="800"/>
               </a:spcAft>
-              <a:defRPr sz="1500">
+              <a:defRPr sz="1300">
                 <a:solidFill>
                   <a:srgbClr val="F8FAFC"/>
                 </a:solidFill>
               </a:defRPr>
             </a:pPr>
             <a:r>
-              <a:t>Step 3 • Entrypoint Specification: Set Main file path to 'app.py' and specify custom application URL.</a:t>
+              <a:t>Verified Metadata: Displays IMDb rating, runtime, director, writer, cast, box office and awards.</a:t>
             </a:r>
           </a:p>
           <a:p>
             <a:pPr>
               <a:spcAft>
-                <a:spcPts val="1000"/>
+                <a:spcPts val="800"/>
               </a:spcAft>
-              <a:defRPr sz="1500">
+              <a:defRPr sz="1300">
                 <a:solidFill>
                   <a:srgbClr val="F8FAFC"/>
                 </a:solidFill>
               </a:defRPr>
             </a:pPr>
             <a:r>
-              <a:t>Step 4 • Auto Backend Discovery: app.py is hardcoded with default cloud backend (https://movie-sentiment-api-cum3.onrender.com).</a:t>
+              <a:t>Narrative Tone Analysis: Passes full plot summary into ML pipeline to categorize storyline tone (e.g. Balanced, Uplifting, Dark).</a:t>
             </a:r>
           </a:p>
           <a:p>
             <a:pPr>
               <a:spcAft>
-                <a:spcPts val="1000"/>
+                <a:spcPts val="800"/>
               </a:spcAft>
-              <a:defRPr sz="1500">
-                <a:solidFill>
-                  <a:srgbClr val="22C55E"/>
+              <a:defRPr sz="1300">
+                <a:solidFill>
+                  <a:srgbClr val="F8FAFC"/>
                 </a:solidFill>
               </a:defRPr>
             </a:pPr>
             <a:r>
-              <a:t>Step 5 • Seamless User Experience: Left sidebar hidden by default for clean cinema mode; connects automatically to cloud API.</a:t>
+              <a:t>Instant Dropdown Search: Quick preset buttons for blockbusters like Sanju, 3 Idiots, Dangal, Inception.</a:t>
             </a:r>
           </a:p>
         </p:txBody>
@@ -3725,8 +3797,8 @@
         </p:nvSpPr>
         <p:spPr>
           <a:xfrm>
-            <a:off x="731520" y="457200"/>
-            <a:ext cx="10698480" cy="1005840"/>
+            <a:off x="731520" y="365760"/>
+            <a:ext cx="10698480" cy="914400"/>
           </a:xfrm>
           <a:prstGeom prst="rect">
             <a:avLst/>
@@ -3747,33 +3819,57 @@
               </a:defRPr>
             </a:pPr>
             <a:r>
-              <a:t>MODEL SPECIFICATIONS</a:t>
+              <a:t>MODEL EVALUATION</a:t>
             </a:r>
           </a:p>
           <a:p>
             <a:pPr>
-              <a:defRPr sz="2600" b="1">
+              <a:defRPr sz="2400" b="1">
                 <a:solidFill>
                   <a:srgbClr val="F8FAFC"/>
                 </a:solidFill>
               </a:defRPr>
             </a:pPr>
             <a:r>
-              <a:t>Machine Learning Architecture &amp; Evaluation</a:t>
-            </a:r>
-          </a:p>
-        </p:txBody>
-      </p:sp>
-      <p:sp>
-        <p:nvSpPr>
-          <p:cNvPr id="3" name="TextBox 2"/>
+              <a:t>Model Performance &amp; Confusion Matrix</a:t>
+            </a:r>
+          </a:p>
+        </p:txBody>
+      </p:sp>
+      <p:pic>
+        <p:nvPicPr>
+          <p:cNvPr id="3" name="Picture 2" descr="4_model_performance_metrics.png"/>
+          <p:cNvPicPr>
+            <a:picLocks noChangeAspect="1"/>
+          </p:cNvPicPr>
+          <p:nvPr/>
+        </p:nvPicPr>
+        <p:blipFill>
+          <a:blip r:embed="rId2"/>
+          <a:stretch>
+            <a:fillRect/>
+          </a:stretch>
+        </p:blipFill>
+        <p:spPr>
+          <a:xfrm>
+            <a:off x="731520" y="1463040"/>
+            <a:ext cx="5852160" cy="3283218"/>
+          </a:xfrm>
+          <a:prstGeom prst="rect">
+            <a:avLst/>
+          </a:prstGeom>
+        </p:spPr>
+      </p:pic>
+      <p:sp>
+        <p:nvSpPr>
+          <p:cNvPr id="4" name="TextBox 3"/>
           <p:cNvSpPr txBox="1"/>
           <p:nvPr/>
         </p:nvSpPr>
         <p:spPr>
           <a:xfrm>
-            <a:off x="731520" y="1645920"/>
-            <a:ext cx="10698480" cy="4572000"/>
+            <a:off x="6766560" y="1463040"/>
+            <a:ext cx="4663440" cy="4754880"/>
           </a:xfrm>
           <a:prstGeom prst="rect">
             <a:avLst/>
@@ -3789,76 +3885,76 @@
           <a:p>
             <a:pPr>
               <a:spcAft>
-                <a:spcPts val="1000"/>
+                <a:spcPts val="800"/>
               </a:spcAft>
-              <a:defRPr sz="1500">
-                <a:solidFill>
-                  <a:srgbClr val="F8FAFC"/>
+              <a:defRPr sz="1300">
+                <a:solidFill>
+                  <a:srgbClr val="22C55E"/>
                 </a:solidFill>
               </a:defRPr>
             </a:pPr>
             <a:r>
-              <a:t>🎯 Dataset &amp; Split: 50,000 IMDb movie reviews divided using 80/20 Stratified Train-Test split for unbiased evaluation.</a:t>
+              <a:t>Benchmark Accuracy: 89.5% accuracy achieved on 20% holdout test set using 80/20 Stratified Split.</a:t>
             </a:r>
           </a:p>
           <a:p>
             <a:pPr>
               <a:spcAft>
-                <a:spcPts val="1000"/>
+                <a:spcPts val="800"/>
               </a:spcAft>
-              <a:defRPr sz="1500">
+              <a:defRPr sz="1300">
                 <a:solidFill>
                   <a:srgbClr val="F8FAFC"/>
                 </a:solidFill>
               </a:defRPr>
             </a:pPr>
             <a:r>
-              <a:t>🔍 Vectorization: TF-IDF Vectorizer with unigrams and bigrams (ngram_range=(1,2)) capturing phrases like 'not good', 'must watch'.</a:t>
+              <a:t>Balanced Metrics: Precision: ~89.2% | Recall: ~89.8% | Macro F1-Score: 0.89.</a:t>
             </a:r>
           </a:p>
           <a:p>
             <a:pPr>
               <a:spcAft>
-                <a:spcPts val="1000"/>
+                <a:spcPts val="800"/>
               </a:spcAft>
-              <a:defRPr sz="1500">
+              <a:defRPr sz="1300">
                 <a:solidFill>
                   <a:srgbClr val="F8FAFC"/>
                 </a:solidFill>
               </a:defRPr>
             </a:pPr>
             <a:r>
-              <a:t>⚖️ Classifier: Logistic Regression with balanced class weighting (C=2.0) trained for calibrated probability output.</a:t>
+              <a:t>Confusion Matrix: Symmetric performance with minimal false positives and false negatives.</a:t>
             </a:r>
           </a:p>
           <a:p>
             <a:pPr>
               <a:spcAft>
-                <a:spcPts val="1000"/>
+                <a:spcPts val="800"/>
               </a:spcAft>
-              <a:defRPr sz="1500">
+              <a:defRPr sz="1300">
                 <a:solidFill>
                   <a:srgbClr val="F8FAFC"/>
                 </a:solidFill>
               </a:defRPr>
             </a:pPr>
             <a:r>
-              <a:t>🛡️ Neutral Threshold Logic: Predictions with confidence &lt; 60% are classified as 'Neutral / Uncertain' to prevent false certainty.</a:t>
+              <a:t>Vocabulary Scope: TF-IDF vectorizer trained with unigrams and bigrams across 50,000 samples.</a:t>
             </a:r>
           </a:p>
           <a:p>
             <a:pPr>
               <a:spcAft>
-                <a:spcPts val="1000"/>
+                <a:spcPts val="800"/>
               </a:spcAft>
-              <a:defRPr sz="1500">
-                <a:solidFill>
-                  <a:srgbClr val="22C55E"/>
+              <a:defRPr sz="1300">
+                <a:solidFill>
+                  <a:srgbClr val="F8FAFC"/>
                 </a:solidFill>
               </a:defRPr>
             </a:pPr>
             <a:r>
-              <a:t>📊 Performance Metrics: Accuracy: ~89.5% | Macro F1-Score: 0.89 | Precision/Recall balanced across Positive and Negative classes.</a:t>
+              <a:t>No Data Leakage: Rigorous holdout testing guarantees real-world generalization on new reviews.</a:t>
             </a:r>
           </a:p>
         </p:txBody>
@@ -3897,8 +3993,8 @@
         </p:nvSpPr>
         <p:spPr>
           <a:xfrm>
-            <a:off x="731520" y="457200"/>
-            <a:ext cx="10698480" cy="1005840"/>
+            <a:off x="731520" y="365760"/>
+            <a:ext cx="10698480" cy="914400"/>
           </a:xfrm>
           <a:prstGeom prst="rect">
             <a:avLst/>
@@ -3919,19 +4015,19 @@
               </a:defRPr>
             </a:pPr>
             <a:r>
-              <a:t>SYSTEM CAPABILITIES</a:t>
+              <a:t>DEPLOYMENT PROCESS</a:t>
             </a:r>
           </a:p>
           <a:p>
             <a:pPr>
-              <a:defRPr sz="2600" b="1">
+              <a:defRPr sz="2400" b="1">
                 <a:solidFill>
                   <a:srgbClr val="F8FAFC"/>
                 </a:solidFill>
               </a:defRPr>
             </a:pPr>
             <a:r>
-              <a:t>Core Application Modules &amp; Features</a:t>
+              <a:t>Complete Step-by-Step Deployment Workflow</a:t>
             </a:r>
           </a:p>
         </p:txBody>
@@ -3944,8 +4040,8 @@
         </p:nvSpPr>
         <p:spPr>
           <a:xfrm>
-            <a:off x="731520" y="1645920"/>
-            <a:ext cx="10698480" cy="4572000"/>
+            <a:off x="731520" y="1463040"/>
+            <a:ext cx="10698480" cy="4754880"/>
           </a:xfrm>
           <a:prstGeom prst="rect">
             <a:avLst/>
@@ -3961,76 +4057,76 @@
           <a:p>
             <a:pPr>
               <a:spcAft>
-                <a:spcPts val="1000"/>
+                <a:spcPts val="800"/>
               </a:spcAft>
-              <a:defRPr sz="1500">
+              <a:defRPr sz="1300">
                 <a:solidFill>
                   <a:srgbClr val="F8FAFC"/>
                 </a:solidFill>
               </a:defRPr>
             </a:pPr>
             <a:r>
-              <a:t>1. Real-Time Single Review Analyzer: Instant prediction with positive/negative confidence meters and Explainable AI (XAI) word attribution.</a:t>
+              <a:t>Step 1 • Model Packaging &amp; Codebase: Trained scikit-learn model serialized via joblib; wrapped inside FastAPI endpoints.</a:t>
             </a:r>
           </a:p>
           <a:p>
             <a:pPr>
               <a:spcAft>
-                <a:spcPts val="1000"/>
+                <a:spcPts val="800"/>
               </a:spcAft>
-              <a:defRPr sz="1500">
-                <a:solidFill>
-                  <a:srgbClr val="F8FAFC"/>
+              <a:defRPr sz="1300">
+                <a:solidFill>
+                  <a:srgbClr val="F5C518"/>
                 </a:solidFill>
               </a:defRPr>
             </a:pPr>
             <a:r>
-              <a:t>2. Bulk Batch CSV Processor: Upload customer review CSVs; batch classifies up to thousands of reviews with exportable annotated results.</a:t>
+              <a:t>Step 2 • Render Cloud API Deployment: Connected GitHub repo to Render ➔ Added uvicorn start command ➔ Live at https://movie-sentiment-api-cum3.onrender.com</a:t>
             </a:r>
           </a:p>
           <a:p>
             <a:pPr>
               <a:spcAft>
-                <a:spcPts val="1000"/>
+                <a:spcPts val="800"/>
               </a:spcAft>
-              <a:defRPr sz="1500">
-                <a:solidFill>
-                  <a:srgbClr val="F8FAFC"/>
+              <a:defRPr sz="1300">
+                <a:solidFill>
+                  <a:srgbClr val="F5C518"/>
                 </a:solidFill>
               </a:defRPr>
             </a:pPr>
             <a:r>
-              <a:t>3. OMDb Movie Explorer with Plot Tone AI: Offline and live search for 58+ Bollywood and Hollywood blockbusters, rendering verified metadata &amp; local posters.</a:t>
+              <a:t>Step 3 • Streamlit Frontend Deployment: Deployed on share.streamlit.io ➔ Hardcoded Render API URL ➔ Live at https://movie-sentiment-app-6yekngedx7cuisepgfajja.streamlit.app/</a:t>
             </a:r>
           </a:p>
           <a:p>
             <a:pPr>
               <a:spcAft>
-                <a:spcPts val="1000"/>
+                <a:spcPts val="800"/>
               </a:spcAft>
-              <a:defRPr sz="1500">
+              <a:defRPr sz="1300">
                 <a:solidFill>
                   <a:srgbClr val="F8FAFC"/>
                 </a:solidFill>
               </a:defRPr>
             </a:pPr>
             <a:r>
-              <a:t>4. Narrative Storyline Sentiment: Applies the ML classifier to full film synopses to gauge underlying emotional and dramatic tone.</a:t>
+              <a:t>Step 4 • Poster Cache Optimization: Downloaded all 58 film posters to static/posters/ to ensure 100% reliable image loading.</a:t>
             </a:r>
           </a:p>
           <a:p>
             <a:pPr>
               <a:spcAft>
-                <a:spcPts val="1000"/>
+                <a:spcPts val="800"/>
               </a:spcAft>
-              <a:defRPr sz="1500">
+              <a:defRPr sz="1300">
                 <a:solidFill>
                   <a:srgbClr val="22C55E"/>
                 </a:solidFill>
               </a:defRPr>
             </a:pPr>
             <a:r>
-              <a:t>5. In-Memory &amp; Local Poster Caching: 58 high-resolution posters bundled locally to prevent Wikimedia CDN rate-limiting (429 errors).</a:t>
+              <a:t>Step 5 • Seamless User Experience: Removed sidebar for clean cinema layout; anyone can open and test on phone or PC without installation.</a:t>
             </a:r>
           </a:p>
         </p:txBody>
@@ -4069,8 +4165,8 @@
         </p:nvSpPr>
         <p:spPr>
           <a:xfrm>
-            <a:off x="731520" y="457200"/>
-            <a:ext cx="10698480" cy="1005840"/>
+            <a:off x="731520" y="365760"/>
+            <a:ext cx="10698480" cy="914400"/>
           </a:xfrm>
           <a:prstGeom prst="rect">
             <a:avLst/>
@@ -4091,19 +4187,19 @@
               </a:defRPr>
             </a:pPr>
             <a:r>
-              <a:t>CONCLUSION &amp; Q&amp;A</a:t>
+              <a:t>SUMMARY</a:t>
             </a:r>
           </a:p>
           <a:p>
             <a:pPr>
-              <a:defRPr sz="2600" b="1">
+              <a:defRPr sz="2400" b="1">
                 <a:solidFill>
                   <a:srgbClr val="F8FAFC"/>
                 </a:solidFill>
               </a:defRPr>
             </a:pPr>
             <a:r>
-              <a:t>Project Summary &amp; Access Credentials</a:t>
+              <a:t>Conclusion &amp; Minor Project Credentials</a:t>
             </a:r>
           </a:p>
         </p:txBody>
@@ -4133,76 +4229,76 @@
           <a:p>
             <a:pPr>
               <a:spcAft>
-                <a:spcPts val="1000"/>
+                <a:spcPts val="800"/>
               </a:spcAft>
-              <a:defRPr sz="1500">
+              <a:defRPr sz="1300">
                 <a:solidFill>
                   <a:srgbClr val="22C55E"/>
                 </a:solidFill>
               </a:defRPr>
             </a:pPr>
             <a:r>
-              <a:t>✅ Achievement: Successfully designed, trained, containerized, and deployed an end-to-end Machine Learning web platform.</a:t>
+              <a:t>Project Outcome: Successfully built and deployed an end-to-end Machine Learning system in full cloud production.</a:t>
             </a:r>
           </a:p>
           <a:p>
             <a:pPr>
               <a:spcAft>
-                <a:spcPts val="1000"/>
+                <a:spcPts val="800"/>
               </a:spcAft>
-              <a:defRPr sz="1500">
-                <a:solidFill>
-                  <a:srgbClr val="F8FAFC"/>
+              <a:defRPr sz="1300">
+                <a:solidFill>
+                  <a:srgbClr val="F5C518"/>
                 </a:solidFill>
               </a:defRPr>
             </a:pPr>
             <a:r>
-              <a:t>🌐 Live Web App: https://movie-sentiment-app-6yekngedx7cuisepgfajja.streamlit.app/</a:t>
+              <a:t>Live Web Application: https://movie-sentiment-app-6yekngedx7cuisepgfajja.streamlit.app/</a:t>
             </a:r>
           </a:p>
           <a:p>
             <a:pPr>
               <a:spcAft>
-                <a:spcPts val="1000"/>
+                <a:spcPts val="800"/>
               </a:spcAft>
-              <a:defRPr sz="1500">
-                <a:solidFill>
-                  <a:srgbClr val="F8FAFC"/>
+              <a:defRPr sz="1300">
+                <a:solidFill>
+                  <a:srgbClr val="F5C518"/>
                 </a:solidFill>
               </a:defRPr>
             </a:pPr>
             <a:r>
-              <a:t>⚙️ Cloud API Docs: https://movie-sentiment-api-cum3.onrender.com/docs</a:t>
+              <a:t>Live Backend Swagger Docs: https://movie-sentiment-api-cum3.onrender.com/docs</a:t>
             </a:r>
           </a:p>
           <a:p>
             <a:pPr>
               <a:spcAft>
-                <a:spcPts val="1000"/>
+                <a:spcPts val="800"/>
               </a:spcAft>
-              <a:defRPr sz="1500">
-                <a:solidFill>
-                  <a:srgbClr val="F8FAFC"/>
+              <a:defRPr sz="1300">
+                <a:solidFill>
+                  <a:srgbClr val="F5C518"/>
                 </a:solidFill>
               </a:defRPr>
             </a:pPr>
             <a:r>
-              <a:t>📂 Open Source Codebase: https://github.com/shivam972410-lang/movie-sentiment-app</a:t>
+              <a:t>GitHub Repository: https://github.com/shivam972410-lang/movie-sentiment-app</a:t>
             </a:r>
           </a:p>
           <a:p>
             <a:pPr>
               <a:spcAft>
-                <a:spcPts val="1000"/>
+                <a:spcPts val="800"/>
               </a:spcAft>
-              <a:defRPr sz="1500">
-                <a:solidFill>
-                  <a:srgbClr val="F5C518"/>
+              <a:defRPr sz="1300">
+                <a:solidFill>
+                  <a:srgbClr val="F8FAFC"/>
                 </a:solidFill>
               </a:defRPr>
             </a:pPr>
             <a:r>
-              <a:t>🎓 Ready for Minor Project Evaluation: All features verified live in cloud production environment.</a:t>
+              <a:t>Ready for Viva &amp; Evaluation: Demonstrates Data Preprocessing, ML Modeling, REST APIs, and Multi-Cloud Deployment.</a:t>
             </a:r>
           </a:p>
         </p:txBody>

</xml_diff>